<commit_message>
Revisão das listas 1-27: correções de conteúdo, numeração e alinhamento com os slides; slides 12, 14, 18 e 19 corrigidos
Co-Authored-By: Claude Opus 5.5 <noreply@anthropic.com>
</commit_message>
<xml_diff>
--- a/content/2026-2/cea055-estatistica-probabilidade/14-aproximacao-normal-revisao/Aula_14_Aproximacao_Normal_Revisao.pptx
+++ b/content/2026-2/cea055-estatistica-probabilidade/14-aproximacao-normal-revisao/Aula_14_Aproximacao_Normal_Revisao.pptx
@@ -4503,7 +4503,7 @@
               <a:p>
                 <a:r>
                   <a:rPr lang="pt-BR" sz="2800" dirty="0"/>
-                  <a:t xml:space="preserve">Seja Y uma v.a. discreta com distribuição </a:t>
+                  <a:t xml:space="preserve">Seja X uma v.a. discreta com distribuição </a:t>
                 </a:r>
                 <a14:m>
                   <m:oMath xmlns:m="http://schemas.openxmlformats.org/officeDocument/2006/math">
@@ -4514,7 +4514,7 @@
                       <a:rPr lang="pt-BR" sz="2800" b="0" i="0" smtClean="0">
                         <a:latin typeface="Cambria Math" panose="02040503050406030204" pitchFamily="18" charset="0"/>
                       </a:rPr>
-                      <m:t>Y</m:t>
+                      <m:t>X</m:t>
                     </m:r>
                     <m:r>
                       <a:rPr lang="pt-BR" sz="2800" b="0" i="1" smtClean="0">
@@ -4675,7 +4675,7 @@
               <a:p>
                 <a:r>
                   <a:rPr lang="pt-BR" sz="2800" dirty="0"/>
-                  <a:t xml:space="preserve">Vamos adaptar a variável Y (discreta) para a v.a. contínua </a:t>
+                  <a:t xml:space="preserve">Vamos adaptar a variável X (discreta) para a v.a. contínua </a:t>
                 </a:r>
                 <a14:m>
                   <m:oMath xmlns:m="http://schemas.openxmlformats.org/officeDocument/2006/math">
@@ -4683,7 +4683,7 @@
                       <a:rPr lang="pt-BR" sz="2800" b="0" i="1" smtClean="0">
                         <a:latin typeface="Cambria Math" panose="02040503050406030204" pitchFamily="18" charset="0"/>
                       </a:rPr>
-                      <m:t>𝑋</m:t>
+                      <m:t>𝑌</m:t>
                     </m:r>
                   </m:oMath>
                 </a14:m>
@@ -4759,7 +4759,7 @@
                       <a:rPr lang="pt-BR" sz="2800" b="0" i="1" dirty="0" smtClean="0">
                         <a:latin typeface="Cambria Math" panose="02040503050406030204" pitchFamily="18" charset="0"/>
                       </a:rPr>
-                      <m:t>𝑋</m:t>
+                      <m:t>𝑌</m:t>
                     </m:r>
                     <m:r>
                       <a:rPr lang="pt-BR" sz="2800" b="0" i="1" dirty="0" smtClean="0">

</xml_diff>